<commit_message>
PPTX: new tagline and revised model ranges on slide 7
Tagline "You Deliver Care, We Optimize Revenue." on the cover; average ED
charge $10,000 (range $3,000–$15,000) so associated gross charges are $90M;
net collection range $500–$5,000. $36M / 9,000 encounters unchanged.

Co-Authored-By: Claude Fable 5.1 <noreply@anthropic.com>
</commit_message>
<xml_diff>
--- a/LaborForce_CookCountyHealth.pptx
+++ b/LaborForce_CookCountyHealth.pptx
@@ -1459,7 +1459,7 @@
           <a:p>
             <a:r>
               <a:rPr lang="en-US" dirty="0"/>
-              <a:t>Static version of the interactive planning model at its starting scenario: 150,000 ED encounters × 6% additional coverage × $4,000 net per encounter = $36M per year; 9,000 identified encounters; $153M associated gross charges at a $17,000 average ED charge. Each figure in the grid = 1,000 ED encounters. Illustrative planning model, not a forecast.</a:t>
+              <a:t>Static version of the interactive planning model at its starting scenario: 150,000 ED encounters × 6% additional coverage × $4,000 net per encounter = $36M per year; 9,000 identified encounters; $90M associated gross charges at a $10,000 average ED charge. Each figure in the grid = 1,000 ED encounters. Illustrative planning model, not a forecast.</a:t>
             </a:r>
             <a:endParaRPr lang="en-US" dirty="0"/>
           </a:p>
@@ -2352,7 +2352,7 @@
                 <a:ea typeface="Segoe UI" pitchFamily="34" charset="-122"/>
                 <a:cs typeface="Segoe UI" pitchFamily="34" charset="-120"/>
               </a:rPr>
-              <a:t>You deliver care. We recover revenue.</a:t>
+              <a:t>You Deliver Care, We Optimize Revenue.</a:t>
             </a:r>
             <a:endParaRPr lang="en-US" sz="1200" dirty="0"/>
           </a:p>
@@ -11169,7 +11169,7 @@
         <p:spPr>
           <a:xfrm>
             <a:off x="548640" y="4279392"/>
-            <a:ext cx="1649957" cy="54864"/>
+            <a:ext cx="3058160" cy="54864"/>
           </a:xfrm>
           <a:prstGeom prst="roundRect">
             <a:avLst>
@@ -11195,7 +11195,7 @@
         </p:nvSpPr>
         <p:spPr>
           <a:xfrm>
-            <a:off x="2125445" y="4233672"/>
+            <a:off x="3533648" y="4233672"/>
             <a:ext cx="146304" cy="146304"/>
           </a:xfrm>
           <a:prstGeom prst="ellipse">
@@ -11245,7 +11245,7 @@
                 <a:ea typeface="Segoe UI" pitchFamily="34" charset="-122"/>
                 <a:cs typeface="Segoe UI" pitchFamily="34" charset="-120"/>
               </a:rPr>
-              <a:t>$1,063</a:t>
+              <a:t>$500</a:t>
             </a:r>
             <a:endParaRPr lang="en-US" sz="850" dirty="0"/>
           </a:p>
@@ -11284,7 +11284,7 @@
                 <a:ea typeface="Segoe UI" pitchFamily="34" charset="-122"/>
                 <a:cs typeface="Segoe UI" pitchFamily="34" charset="-120"/>
               </a:rPr>
-              <a:t>$8,062</a:t>
+              <a:t>$5,000</a:t>
             </a:r>
             <a:endParaRPr lang="en-US" sz="850" dirty="0"/>
           </a:p>
@@ -11399,7 +11399,7 @@
                 <a:ea typeface="Segoe UI" pitchFamily="34" charset="-122"/>
                 <a:cs typeface="Segoe UI" pitchFamily="34" charset="-120"/>
               </a:rPr>
-              <a:t>$17,000</a:t>
+              <a:t>$10,000</a:t>
             </a:r>
             <a:endParaRPr lang="en-US" sz="1700" dirty="0"/>
           </a:p>
@@ -11441,7 +11441,7 @@
         <p:spPr>
           <a:xfrm>
             <a:off x="548640" y="5193792"/>
-            <a:ext cx="3194685" cy="54864"/>
+            <a:ext cx="2293620" cy="54864"/>
           </a:xfrm>
           <a:prstGeom prst="roundRect">
             <a:avLst>
@@ -11467,7 +11467,7 @@
         </p:nvSpPr>
         <p:spPr>
           <a:xfrm>
-            <a:off x="3670173" y="5148072"/>
+            <a:off x="2769108" y="5148072"/>
             <a:ext cx="146304" cy="146304"/>
           </a:xfrm>
           <a:prstGeom prst="ellipse">
@@ -11517,7 +11517,7 @@
                 <a:ea typeface="Segoe UI" pitchFamily="34" charset="-122"/>
                 <a:cs typeface="Segoe UI" pitchFamily="34" charset="-120"/>
               </a:rPr>
-              <a:t>$4,000</a:t>
+              <a:t>$3,000</a:t>
             </a:r>
             <a:endParaRPr lang="en-US" sz="850" dirty="0"/>
           </a:p>
@@ -11556,7 +11556,7 @@
                 <a:ea typeface="Segoe UI" pitchFamily="34" charset="-122"/>
                 <a:cs typeface="Segoe UI" pitchFamily="34" charset="-120"/>
               </a:rPr>
-              <a:t>$20,000</a:t>
+              <a:t>$15,000</a:t>
             </a:r>
             <a:endParaRPr lang="en-US" sz="850" dirty="0"/>
           </a:p>
@@ -11909,7 +11909,7 @@
                 <a:ea typeface="Segoe UI" pitchFamily="34" charset="-122"/>
                 <a:cs typeface="Segoe UI" pitchFamily="34" charset="-120"/>
               </a:rPr>
-              <a:t>$153M</a:t>
+              <a:t>$90M</a:t>
             </a:r>
             <a:endParaRPr lang="en-US" sz="2800" dirty="0"/>
           </a:p>

</xml_diff>

<commit_message>
PPTX cover: remove the Prepared for / Prepared by / Briefing row
Cover now shows only the tagline, title and subtitle, vertically centred in
the left column, plus the footer line and the "At a glance" panel. No logo on
the slide body.

Co-Authored-By: Claude Fable 5.1 <noreply@anthropic.com>
</commit_message>
<xml_diff>
--- a/LaborForce_CookCountyHealth.pptx
+++ b/LaborForce_CookCountyHealth.pptx
@@ -2327,7 +2327,7 @@
         </p:nvSpPr>
         <p:spPr>
           <a:xfrm>
-            <a:off x="548640" y="1325880"/>
+            <a:off x="548640" y="1783080"/>
             <a:ext cx="5486400" cy="274320"/>
           </a:xfrm>
           <a:prstGeom prst="rect">
@@ -2366,7 +2366,7 @@
         </p:nvSpPr>
         <p:spPr>
           <a:xfrm>
-            <a:off x="548640" y="1645920"/>
+            <a:off x="548640" y="2103120"/>
             <a:ext cx="6675120" cy="1783080"/>
           </a:xfrm>
           <a:prstGeom prst="rect">
@@ -2428,7 +2428,7 @@
         </p:nvSpPr>
         <p:spPr>
           <a:xfrm>
-            <a:off x="548640" y="3520440"/>
+            <a:off x="548640" y="3977640"/>
             <a:ext cx="5120640" cy="868680"/>
           </a:xfrm>
           <a:prstGeom prst="rect">
@@ -2470,14 +2470,117 @@
         </p:nvSpPr>
         <p:spPr>
           <a:xfrm>
-            <a:off x="548640" y="4846320"/>
+            <a:off x="548640" y="6382512"/>
             <a:ext cx="6675120" cy="0"/>
           </a:xfrm>
           <a:prstGeom prst="line">
             <a:avLst/>
           </a:prstGeom>
           <a:noFill/>
-          <a:ln w="19050">
+          <a:ln w="9525">
+            <a:solidFill>
+              <a:srgbClr val="D4DCE6"/>
+            </a:solidFill>
+            <a:prstDash val="solid"/>
+          </a:ln>
+        </p:spPr>
+      </p:sp>
+      <p:sp>
+        <p:nvSpPr>
+          <p:cNvPr id="6" name="Text 4"/>
+          <p:cNvSpPr txBox="1"/>
+          <p:nvPr/>
+        </p:nvSpPr>
+        <p:spPr>
+          <a:xfrm>
+            <a:off x="548640" y="6455664"/>
+            <a:ext cx="4572000" cy="228600"/>
+          </a:xfrm>
+          <a:prstGeom prst="rect">
+            <a:avLst/>
+          </a:prstGeom>
+          <a:noFill/>
+          <a:ln/>
+        </p:spPr>
+        <p:txBody>
+          <a:bodyPr wrap="square" lIns="0" tIns="0" rIns="0" bIns="0" rtlCol="0" anchor="t"/>
+          <a:lstStyle/>
+          <a:p>
+            <a:pPr indent="0" marL="0">
+              <a:buNone/>
+            </a:pPr>
+            <a:r>
+              <a:rPr lang="en-US" sz="800" spc="150" kern="0" dirty="0">
+                <a:solidFill>
+                  <a:srgbClr val="6E7E90"/>
+                </a:solidFill>
+                <a:latin typeface="Segoe UI" pitchFamily="34" charset="0"/>
+                <a:ea typeface="Segoe UI" pitchFamily="34" charset="-122"/>
+                <a:cs typeface="Segoe UI" pitchFamily="34" charset="-120"/>
+              </a:rPr>
+              <a:t>CONFIDENTIAL — FOR DISCUSSION PURPOSES</a:t>
+            </a:r>
+            <a:endParaRPr lang="en-US" sz="800" dirty="0"/>
+          </a:p>
+        </p:txBody>
+      </p:sp>
+      <p:sp>
+        <p:nvSpPr>
+          <p:cNvPr id="7" name="Text 5"/>
+          <p:cNvSpPr txBox="1"/>
+          <p:nvPr/>
+        </p:nvSpPr>
+        <p:spPr>
+          <a:xfrm>
+            <a:off x="5394960" y="6455664"/>
+            <a:ext cx="1828800" cy="228600"/>
+          </a:xfrm>
+          <a:prstGeom prst="rect">
+            <a:avLst/>
+          </a:prstGeom>
+          <a:noFill/>
+          <a:ln/>
+        </p:spPr>
+        <p:txBody>
+          <a:bodyPr wrap="square" lIns="0" tIns="0" rIns="0" bIns="0" rtlCol="0" anchor="t"/>
+          <a:lstStyle/>
+          <a:p>
+            <a:pPr algn="r" indent="0" marL="0">
+              <a:buNone/>
+            </a:pPr>
+            <a:r>
+              <a:rPr lang="en-US" sz="800" spc="150" kern="0" dirty="0">
+                <a:solidFill>
+                  <a:srgbClr val="6E7E90"/>
+                </a:solidFill>
+                <a:latin typeface="Segoe UI" pitchFamily="34" charset="0"/>
+                <a:ea typeface="Segoe UI" pitchFamily="34" charset="-122"/>
+                <a:cs typeface="Segoe UI" pitchFamily="34" charset="-120"/>
+              </a:rPr>
+              <a:t>01 / 10</a:t>
+            </a:r>
+            <a:endParaRPr lang="en-US" sz="800" dirty="0"/>
+          </a:p>
+        </p:txBody>
+      </p:sp>
+      <p:sp>
+        <p:nvSpPr>
+          <p:cNvPr id="8" name="Shape 6"/>
+          <p:cNvSpPr/>
+          <p:nvPr/>
+        </p:nvSpPr>
+        <p:spPr>
+          <a:xfrm>
+            <a:off x="7726680" y="0"/>
+            <a:ext cx="4465015" cy="6858000"/>
+          </a:xfrm>
+          <a:prstGeom prst="rect">
+            <a:avLst/>
+          </a:prstGeom>
+          <a:solidFill>
+            <a:srgbClr val="0C3C75"/>
+          </a:solidFill>
+          <a:ln w="12700">
             <a:solidFill>
               <a:srgbClr val="0C3C75"/>
             </a:solidFill>
@@ -2487,53 +2590,117 @@
       </p:sp>
       <p:sp>
         <p:nvSpPr>
-          <p:cNvPr id="6" name="Text 4"/>
-          <p:cNvSpPr txBox="1"/>
-          <p:nvPr/>
-        </p:nvSpPr>
-        <p:spPr>
-          <a:xfrm>
-            <a:off x="548640" y="5047488"/>
-            <a:ext cx="2834640" cy="201168"/>
-          </a:xfrm>
-          <a:prstGeom prst="rect">
-            <a:avLst/>
-          </a:prstGeom>
-          <a:noFill/>
-          <a:ln/>
-        </p:spPr>
-        <p:txBody>
-          <a:bodyPr wrap="square" lIns="0" tIns="0" rIns="0" bIns="0" rtlCol="0" anchor="t"/>
-          <a:lstStyle/>
-          <a:p>
-            <a:pPr indent="0" marL="0">
-              <a:buNone/>
-            </a:pPr>
-            <a:r>
-              <a:rPr lang="en-US" sz="800" b="1" spc="150" kern="0" dirty="0">
-                <a:solidFill>
-                  <a:srgbClr val="6E7E90"/>
-                </a:solidFill>
-                <a:latin typeface="Segoe UI" pitchFamily="34" charset="0"/>
-                <a:ea typeface="Segoe UI" pitchFamily="34" charset="-122"/>
-                <a:cs typeface="Segoe UI" pitchFamily="34" charset="-120"/>
-              </a:rPr>
-              <a:t>PREPARED FOR</a:t>
-            </a:r>
-            <a:endParaRPr lang="en-US" sz="800" dirty="0"/>
-          </a:p>
-        </p:txBody>
-      </p:sp>
-      <p:sp>
-        <p:nvSpPr>
-          <p:cNvPr id="7" name="Text 5"/>
-          <p:cNvSpPr txBox="1"/>
-          <p:nvPr/>
-        </p:nvSpPr>
-        <p:spPr>
-          <a:xfrm>
-            <a:off x="548640" y="5285232"/>
-            <a:ext cx="2834640" cy="594360"/>
+          <p:cNvPr id="9" name="Shape 7"/>
+          <p:cNvSpPr/>
+          <p:nvPr/>
+        </p:nvSpPr>
+        <p:spPr>
+          <a:xfrm>
+            <a:off x="7726680" y="0"/>
+            <a:ext cx="54864" cy="6858000"/>
+          </a:xfrm>
+          <a:prstGeom prst="rect">
+            <a:avLst/>
+          </a:prstGeom>
+          <a:solidFill>
+            <a:srgbClr val="0A8FA6"/>
+          </a:solidFill>
+          <a:ln w="12700">
+            <a:solidFill>
+              <a:srgbClr val="0A8FA6"/>
+            </a:solidFill>
+            <a:prstDash val="solid"/>
+          </a:ln>
+        </p:spPr>
+      </p:sp>
+      <p:sp>
+        <p:nvSpPr>
+          <p:cNvPr id="10" name="Text 8"/>
+          <p:cNvSpPr txBox="1"/>
+          <p:nvPr/>
+        </p:nvSpPr>
+        <p:spPr>
+          <a:xfrm>
+            <a:off x="8183880" y="548640"/>
+            <a:ext cx="3596335" cy="201168"/>
+          </a:xfrm>
+          <a:prstGeom prst="rect">
+            <a:avLst/>
+          </a:prstGeom>
+          <a:noFill/>
+          <a:ln/>
+        </p:spPr>
+        <p:txBody>
+          <a:bodyPr wrap="square" lIns="0" tIns="0" rIns="0" bIns="0" rtlCol="0" anchor="t"/>
+          <a:lstStyle/>
+          <a:p>
+            <a:pPr indent="0" marL="0">
+              <a:buNone/>
+            </a:pPr>
+            <a:r>
+              <a:rPr lang="en-US" sz="900" b="1" spc="150" kern="0" dirty="0">
+                <a:solidFill>
+                  <a:srgbClr val="7FD3E3"/>
+                </a:solidFill>
+                <a:latin typeface="Segoe UI" pitchFamily="34" charset="0"/>
+                <a:ea typeface="Segoe UI" pitchFamily="34" charset="-122"/>
+                <a:cs typeface="Segoe UI" pitchFamily="34" charset="-120"/>
+              </a:rPr>
+              <a:t>AT A GLANCE</a:t>
+            </a:r>
+            <a:endParaRPr lang="en-US" sz="900" dirty="0"/>
+          </a:p>
+        </p:txBody>
+      </p:sp>
+      <p:sp>
+        <p:nvSpPr>
+          <p:cNvPr id="11" name="Text 9"/>
+          <p:cNvSpPr txBox="1"/>
+          <p:nvPr/>
+        </p:nvSpPr>
+        <p:spPr>
+          <a:xfrm>
+            <a:off x="8183880" y="914400"/>
+            <a:ext cx="3596335" cy="566928"/>
+          </a:xfrm>
+          <a:prstGeom prst="rect">
+            <a:avLst/>
+          </a:prstGeom>
+          <a:noFill/>
+          <a:ln/>
+        </p:spPr>
+        <p:txBody>
+          <a:bodyPr wrap="square" lIns="0" tIns="0" rIns="0" bIns="0" rtlCol="0" anchor="t"/>
+          <a:lstStyle/>
+          <a:p>
+            <a:pPr indent="0" marL="0">
+              <a:buNone/>
+            </a:pPr>
+            <a:r>
+              <a:rPr lang="en-US" sz="3800" spc="-200" kern="0" dirty="0">
+                <a:solidFill>
+                  <a:srgbClr val="FFFFFF"/>
+                </a:solidFill>
+                <a:latin typeface="Segoe UI" pitchFamily="34" charset="0"/>
+                <a:ea typeface="Segoe UI" pitchFamily="34" charset="-122"/>
+                <a:cs typeface="Segoe UI" pitchFamily="34" charset="-120"/>
+              </a:rPr>
+              <a:t>+336%</a:t>
+            </a:r>
+            <a:endParaRPr lang="en-US" sz="3800" dirty="0"/>
+          </a:p>
+        </p:txBody>
+      </p:sp>
+      <p:sp>
+        <p:nvSpPr>
+          <p:cNvPr id="12" name="Text 10"/>
+          <p:cNvSpPr txBox="1"/>
+          <p:nvPr/>
+        </p:nvSpPr>
+        <p:spPr>
+          <a:xfrm>
+            <a:off x="8183880" y="1517904"/>
+            <a:ext cx="3596335" cy="457200"/>
           </a:xfrm>
           <a:prstGeom prst="rect">
             <a:avLst/>
@@ -2552,18 +2719,102 @@
               <a:buNone/>
             </a:pPr>
             <a:r>
-              <a:rPr lang="en-US" sz="1050" b="1" dirty="0">
-                <a:solidFill>
-                  <a:srgbClr val="0C3C75"/>
-                </a:solidFill>
-                <a:latin typeface="Segoe UI" pitchFamily="34" charset="0"/>
-                <a:ea typeface="Segoe UI" pitchFamily="34" charset="-122"/>
-                <a:cs typeface="Segoe UI" pitchFamily="34" charset="-120"/>
-              </a:rPr>
-              <a:t>Cook County Health</a:t>
+              <a:rPr lang="en-US" sz="1050" dirty="0">
+                <a:solidFill>
+                  <a:srgbClr val="C5D6E8"/>
+                </a:solidFill>
+                <a:latin typeface="Segoe UI" pitchFamily="34" charset="0"/>
+                <a:ea typeface="Segoe UI" pitchFamily="34" charset="-122"/>
+                <a:cs typeface="Segoe UI" pitchFamily="34" charset="-120"/>
+              </a:rPr>
+              <a:t>Monthly TPL recoveries at Chicago-area partner hospitals, March – July 2026 ($33K → $144K)</a:t>
             </a:r>
             <a:endParaRPr lang="en-US" sz="1050" dirty="0"/>
           </a:p>
+        </p:txBody>
+      </p:sp>
+      <p:sp>
+        <p:nvSpPr>
+          <p:cNvPr id="13" name="Shape 11"/>
+          <p:cNvSpPr/>
+          <p:nvPr/>
+        </p:nvSpPr>
+        <p:spPr>
+          <a:xfrm>
+            <a:off x="8183880" y="1993392"/>
+            <a:ext cx="3596335" cy="0"/>
+          </a:xfrm>
+          <a:prstGeom prst="line">
+            <a:avLst/>
+          </a:prstGeom>
+          <a:noFill/>
+          <a:ln w="9525">
+            <a:solidFill>
+              <a:srgbClr val="375F8F"/>
+            </a:solidFill>
+            <a:prstDash val="solid"/>
+          </a:ln>
+        </p:spPr>
+      </p:sp>
+      <p:sp>
+        <p:nvSpPr>
+          <p:cNvPr id="14" name="Text 12"/>
+          <p:cNvSpPr txBox="1"/>
+          <p:nvPr/>
+        </p:nvSpPr>
+        <p:spPr>
+          <a:xfrm>
+            <a:off x="8183880" y="2103120"/>
+            <a:ext cx="3596335" cy="566928"/>
+          </a:xfrm>
+          <a:prstGeom prst="rect">
+            <a:avLst/>
+          </a:prstGeom>
+          <a:noFill/>
+          <a:ln/>
+        </p:spPr>
+        <p:txBody>
+          <a:bodyPr wrap="square" lIns="0" tIns="0" rIns="0" bIns="0" rtlCol="0" anchor="t"/>
+          <a:lstStyle/>
+          <a:p>
+            <a:pPr indent="0" marL="0">
+              <a:buNone/>
+            </a:pPr>
+            <a:r>
+              <a:rPr lang="en-US" sz="3800" spc="-200" kern="0" dirty="0">
+                <a:solidFill>
+                  <a:srgbClr val="FFFFFF"/>
+                </a:solidFill>
+                <a:latin typeface="Segoe UI" pitchFamily="34" charset="0"/>
+                <a:ea typeface="Segoe UI" pitchFamily="34" charset="-122"/>
+                <a:cs typeface="Segoe UI" pitchFamily="34" charset="-120"/>
+              </a:rPr>
+              <a:t>90%+</a:t>
+            </a:r>
+            <a:endParaRPr lang="en-US" sz="3800" dirty="0"/>
+          </a:p>
+        </p:txBody>
+      </p:sp>
+      <p:sp>
+        <p:nvSpPr>
+          <p:cNvPr id="15" name="Text 13"/>
+          <p:cNvSpPr txBox="1"/>
+          <p:nvPr/>
+        </p:nvSpPr>
+        <p:spPr>
+          <a:xfrm>
+            <a:off x="8183880" y="2706624"/>
+            <a:ext cx="3596335" cy="457200"/>
+          </a:xfrm>
+          <a:prstGeom prst="rect">
+            <a:avLst/>
+          </a:prstGeom>
+          <a:noFill/>
+          <a:ln/>
+        </p:spPr>
+        <p:txBody>
+          <a:bodyPr wrap="square" lIns="0" tIns="0" rIns="0" bIns="0" rtlCol="0" anchor="t"/>
+          <a:lstStyle/>
           <a:p>
             <a:pPr indent="0" marL="0">
               <a:lnSpc>
@@ -2572,15 +2823,15 @@
               <a:buNone/>
             </a:pPr>
             <a:r>
-              <a:rPr lang="en-US" sz="1050" b="1" dirty="0">
-                <a:solidFill>
-                  <a:srgbClr val="0C3C75"/>
-                </a:solidFill>
-                <a:latin typeface="Segoe UI" pitchFamily="34" charset="0"/>
-                <a:ea typeface="Segoe UI" pitchFamily="34" charset="-122"/>
-                <a:cs typeface="Segoe UI" pitchFamily="34" charset="-120"/>
-              </a:rPr>
-              <a:t>Executive Leadership — CEO · CFO · COO</a:t>
+              <a:rPr lang="en-US" sz="1050" dirty="0">
+                <a:solidFill>
+                  <a:srgbClr val="C5D6E8"/>
+                </a:solidFill>
+                <a:latin typeface="Segoe UI" pitchFamily="34" charset="0"/>
+                <a:ea typeface="Segoe UI" pitchFamily="34" charset="-122"/>
+                <a:cs typeface="Segoe UI" pitchFamily="34" charset="-120"/>
+              </a:rPr>
+              <a:t>Payer identification accuracy, up from under 30%</a:t>
             </a:r>
             <a:endParaRPr lang="en-US" sz="1050" dirty="0"/>
           </a:p>
@@ -2588,116 +2839,76 @@
       </p:sp>
       <p:sp>
         <p:nvSpPr>
-          <p:cNvPr id="8" name="Text 6"/>
-          <p:cNvSpPr txBox="1"/>
-          <p:nvPr/>
-        </p:nvSpPr>
-        <p:spPr>
-          <a:xfrm>
-            <a:off x="3657600" y="5047488"/>
-            <a:ext cx="1737360" cy="201168"/>
-          </a:xfrm>
-          <a:prstGeom prst="rect">
-            <a:avLst/>
-          </a:prstGeom>
-          <a:noFill/>
-          <a:ln/>
-        </p:spPr>
-        <p:txBody>
-          <a:bodyPr wrap="square" lIns="0" tIns="0" rIns="0" bIns="0" rtlCol="0" anchor="t"/>
-          <a:lstStyle/>
-          <a:p>
-            <a:pPr indent="0" marL="0">
-              <a:buNone/>
-            </a:pPr>
-            <a:r>
-              <a:rPr lang="en-US" sz="800" b="1" spc="150" kern="0" dirty="0">
-                <a:solidFill>
-                  <a:srgbClr val="6E7E90"/>
-                </a:solidFill>
-                <a:latin typeface="Segoe UI" pitchFamily="34" charset="0"/>
-                <a:ea typeface="Segoe UI" pitchFamily="34" charset="-122"/>
-                <a:cs typeface="Segoe UI" pitchFamily="34" charset="-120"/>
-              </a:rPr>
-              <a:t>PREPARED BY</a:t>
-            </a:r>
-            <a:endParaRPr lang="en-US" sz="800" dirty="0"/>
-          </a:p>
-        </p:txBody>
-      </p:sp>
-      <p:pic>
-        <p:nvPicPr>
-          <p:cNvPr id="9" name="Image 0" descr="E:/Claude/laborforce-deck/brand/logo_full_large.png">    </p:cNvPr>
-          <p:cNvPicPr>
-            <a:picLocks noChangeAspect="1"/>
-          </p:cNvPicPr>
-          <p:nvPr/>
-        </p:nvPicPr>
-        <p:blipFill>
-          <a:blip r:embed="rId1"/>
-          <a:stretch>
-            <a:fillRect/>
-          </a:stretch>
-        </p:blipFill>
-        <p:spPr>
-          <a:xfrm>
-            <a:off x="3657600" y="5266944"/>
-            <a:ext cx="896112" cy="589788"/>
-          </a:xfrm>
-          <a:prstGeom prst="rect">
-            <a:avLst/>
-          </a:prstGeom>
-        </p:spPr>
-      </p:pic>
-      <p:sp>
-        <p:nvSpPr>
-          <p:cNvPr id="10" name="Text 7"/>
-          <p:cNvSpPr txBox="1"/>
-          <p:nvPr/>
-        </p:nvSpPr>
-        <p:spPr>
-          <a:xfrm>
-            <a:off x="5577840" y="5047488"/>
-            <a:ext cx="1645920" cy="201168"/>
-          </a:xfrm>
-          <a:prstGeom prst="rect">
-            <a:avLst/>
-          </a:prstGeom>
-          <a:noFill/>
-          <a:ln/>
-        </p:spPr>
-        <p:txBody>
-          <a:bodyPr wrap="square" lIns="0" tIns="0" rIns="0" bIns="0" rtlCol="0" anchor="t"/>
-          <a:lstStyle/>
-          <a:p>
-            <a:pPr indent="0" marL="0">
-              <a:buNone/>
-            </a:pPr>
-            <a:r>
-              <a:rPr lang="en-US" sz="800" b="1" spc="150" kern="0" dirty="0">
-                <a:solidFill>
-                  <a:srgbClr val="6E7E90"/>
-                </a:solidFill>
-                <a:latin typeface="Segoe UI" pitchFamily="34" charset="0"/>
-                <a:ea typeface="Segoe UI" pitchFamily="34" charset="-122"/>
-                <a:cs typeface="Segoe UI" pitchFamily="34" charset="-120"/>
-              </a:rPr>
-              <a:t>BRIEFING</a:t>
-            </a:r>
-            <a:endParaRPr lang="en-US" sz="800" dirty="0"/>
-          </a:p>
-        </p:txBody>
-      </p:sp>
-      <p:sp>
-        <p:nvSpPr>
-          <p:cNvPr id="11" name="Text 8"/>
-          <p:cNvSpPr txBox="1"/>
-          <p:nvPr/>
-        </p:nvSpPr>
-        <p:spPr>
-          <a:xfrm>
-            <a:off x="5577840" y="5285232"/>
-            <a:ext cx="1645920" cy="594360"/>
+          <p:cNvPr id="16" name="Shape 14"/>
+          <p:cNvSpPr/>
+          <p:nvPr/>
+        </p:nvSpPr>
+        <p:spPr>
+          <a:xfrm>
+            <a:off x="8183880" y="3182112"/>
+            <a:ext cx="3596335" cy="0"/>
+          </a:xfrm>
+          <a:prstGeom prst="line">
+            <a:avLst/>
+          </a:prstGeom>
+          <a:noFill/>
+          <a:ln w="9525">
+            <a:solidFill>
+              <a:srgbClr val="375F8F"/>
+            </a:solidFill>
+            <a:prstDash val="solid"/>
+          </a:ln>
+        </p:spPr>
+      </p:sp>
+      <p:sp>
+        <p:nvSpPr>
+          <p:cNvPr id="17" name="Text 15"/>
+          <p:cNvSpPr txBox="1"/>
+          <p:nvPr/>
+        </p:nvSpPr>
+        <p:spPr>
+          <a:xfrm>
+            <a:off x="8183880" y="3291840"/>
+            <a:ext cx="3596335" cy="566928"/>
+          </a:xfrm>
+          <a:prstGeom prst="rect">
+            <a:avLst/>
+          </a:prstGeom>
+          <a:noFill/>
+          <a:ln/>
+        </p:spPr>
+        <p:txBody>
+          <a:bodyPr wrap="square" lIns="0" tIns="0" rIns="0" bIns="0" rtlCol="0" anchor="t"/>
+          <a:lstStyle/>
+          <a:p>
+            <a:pPr indent="0" marL="0">
+              <a:buNone/>
+            </a:pPr>
+            <a:r>
+              <a:rPr lang="en-US" sz="3800" spc="-200" kern="0" dirty="0">
+                <a:solidFill>
+                  <a:srgbClr val="FFFFFF"/>
+                </a:solidFill>
+                <a:latin typeface="Segoe UI" pitchFamily="34" charset="0"/>
+                <a:ea typeface="Segoe UI" pitchFamily="34" charset="-122"/>
+                <a:cs typeface="Segoe UI" pitchFamily="34" charset="-120"/>
+              </a:rPr>
+              <a:t>79%</a:t>
+            </a:r>
+            <a:endParaRPr lang="en-US" sz="3800" dirty="0"/>
+          </a:p>
+        </p:txBody>
+      </p:sp>
+      <p:sp>
+        <p:nvSpPr>
+          <p:cNvPr id="18" name="Text 16"/>
+          <p:cNvSpPr txBox="1"/>
+          <p:nvPr/>
+        </p:nvSpPr>
+        <p:spPr>
+          <a:xfrm>
+            <a:off x="8183880" y="3895344"/>
+            <a:ext cx="3596335" cy="457200"/>
           </a:xfrm>
           <a:prstGeom prst="rect">
             <a:avLst/>
@@ -2716,522 +2927,23 @@
               <a:buNone/>
             </a:pPr>
             <a:r>
-              <a:rPr lang="en-US" sz="1050" b="1" dirty="0">
-                <a:solidFill>
-                  <a:srgbClr val="0C3C75"/>
-                </a:solidFill>
-                <a:latin typeface="Segoe UI" pitchFamily="34" charset="0"/>
-                <a:ea typeface="Segoe UI" pitchFamily="34" charset="-122"/>
-                <a:cs typeface="Segoe UI" pitchFamily="34" charset="-120"/>
-              </a:rPr>
-              <a:t>Executive proposal</a:t>
+              <a:rPr lang="en-US" sz="1050" dirty="0">
+                <a:solidFill>
+                  <a:srgbClr val="C5D6E8"/>
+                </a:solidFill>
+                <a:latin typeface="Segoe UI" pitchFamily="34" charset="0"/>
+                <a:ea typeface="Segoe UI" pitchFamily="34" charset="-122"/>
+                <a:cs typeface="Segoe UI" pitchFamily="34" charset="-120"/>
+              </a:rPr>
+              <a:t>Of screened July encounters verified (141 of 178)</a:t>
             </a:r>
             <a:endParaRPr lang="en-US" sz="1050" dirty="0"/>
           </a:p>
-          <a:p>
-            <a:pPr indent="0" marL="0">
-              <a:lnSpc>
-                <a:spcPct val="120000"/>
-              </a:lnSpc>
-              <a:buNone/>
-            </a:pPr>
-            <a:r>
-              <a:rPr lang="en-US" sz="1050" b="1" dirty="0">
-                <a:solidFill>
-                  <a:srgbClr val="0C3C75"/>
-                </a:solidFill>
-                <a:latin typeface="Segoe UI" pitchFamily="34" charset="0"/>
-                <a:ea typeface="Segoe UI" pitchFamily="34" charset="-122"/>
-                <a:cs typeface="Segoe UI" pitchFamily="34" charset="-120"/>
-              </a:rPr>
-              <a:t>October 2026</a:t>
-            </a:r>
-            <a:endParaRPr lang="en-US" sz="1050" dirty="0"/>
-          </a:p>
-        </p:txBody>
-      </p:sp>
-      <p:sp>
-        <p:nvSpPr>
-          <p:cNvPr id="12" name="Shape 9"/>
-          <p:cNvSpPr/>
-          <p:nvPr/>
-        </p:nvSpPr>
-        <p:spPr>
-          <a:xfrm>
-            <a:off x="548640" y="6382512"/>
-            <a:ext cx="6675120" cy="0"/>
-          </a:xfrm>
-          <a:prstGeom prst="line">
-            <a:avLst/>
-          </a:prstGeom>
-          <a:noFill/>
-          <a:ln w="9525">
-            <a:solidFill>
-              <a:srgbClr val="D4DCE6"/>
-            </a:solidFill>
-            <a:prstDash val="solid"/>
-          </a:ln>
-        </p:spPr>
-      </p:sp>
-      <p:sp>
-        <p:nvSpPr>
-          <p:cNvPr id="13" name="Text 10"/>
-          <p:cNvSpPr txBox="1"/>
-          <p:nvPr/>
-        </p:nvSpPr>
-        <p:spPr>
-          <a:xfrm>
-            <a:off x="548640" y="6455664"/>
-            <a:ext cx="4572000" cy="228600"/>
-          </a:xfrm>
-          <a:prstGeom prst="rect">
-            <a:avLst/>
-          </a:prstGeom>
-          <a:noFill/>
-          <a:ln/>
-        </p:spPr>
-        <p:txBody>
-          <a:bodyPr wrap="square" lIns="0" tIns="0" rIns="0" bIns="0" rtlCol="0" anchor="t"/>
-          <a:lstStyle/>
-          <a:p>
-            <a:pPr indent="0" marL="0">
-              <a:buNone/>
-            </a:pPr>
-            <a:r>
-              <a:rPr lang="en-US" sz="800" spc="150" kern="0" dirty="0">
-                <a:solidFill>
-                  <a:srgbClr val="6E7E90"/>
-                </a:solidFill>
-                <a:latin typeface="Segoe UI" pitchFamily="34" charset="0"/>
-                <a:ea typeface="Segoe UI" pitchFamily="34" charset="-122"/>
-                <a:cs typeface="Segoe UI" pitchFamily="34" charset="-120"/>
-              </a:rPr>
-              <a:t>CONFIDENTIAL — FOR DISCUSSION PURPOSES</a:t>
-            </a:r>
-            <a:endParaRPr lang="en-US" sz="800" dirty="0"/>
-          </a:p>
-        </p:txBody>
-      </p:sp>
-      <p:sp>
-        <p:nvSpPr>
-          <p:cNvPr id="14" name="Text 11"/>
-          <p:cNvSpPr txBox="1"/>
-          <p:nvPr/>
-        </p:nvSpPr>
-        <p:spPr>
-          <a:xfrm>
-            <a:off x="5394960" y="6455664"/>
-            <a:ext cx="1828800" cy="228600"/>
-          </a:xfrm>
-          <a:prstGeom prst="rect">
-            <a:avLst/>
-          </a:prstGeom>
-          <a:noFill/>
-          <a:ln/>
-        </p:spPr>
-        <p:txBody>
-          <a:bodyPr wrap="square" lIns="0" tIns="0" rIns="0" bIns="0" rtlCol="0" anchor="t"/>
-          <a:lstStyle/>
-          <a:p>
-            <a:pPr algn="r" indent="0" marL="0">
-              <a:buNone/>
-            </a:pPr>
-            <a:r>
-              <a:rPr lang="en-US" sz="800" spc="150" kern="0" dirty="0">
-                <a:solidFill>
-                  <a:srgbClr val="6E7E90"/>
-                </a:solidFill>
-                <a:latin typeface="Segoe UI" pitchFamily="34" charset="0"/>
-                <a:ea typeface="Segoe UI" pitchFamily="34" charset="-122"/>
-                <a:cs typeface="Segoe UI" pitchFamily="34" charset="-120"/>
-              </a:rPr>
-              <a:t>01 / 10</a:t>
-            </a:r>
-            <a:endParaRPr lang="en-US" sz="800" dirty="0"/>
-          </a:p>
-        </p:txBody>
-      </p:sp>
-      <p:sp>
-        <p:nvSpPr>
-          <p:cNvPr id="15" name="Shape 12"/>
-          <p:cNvSpPr/>
-          <p:nvPr/>
-        </p:nvSpPr>
-        <p:spPr>
-          <a:xfrm>
-            <a:off x="7726680" y="0"/>
-            <a:ext cx="4465015" cy="6858000"/>
-          </a:xfrm>
-          <a:prstGeom prst="rect">
-            <a:avLst/>
-          </a:prstGeom>
-          <a:solidFill>
-            <a:srgbClr val="0C3C75"/>
-          </a:solidFill>
-          <a:ln w="12700">
-            <a:solidFill>
-              <a:srgbClr val="0C3C75"/>
-            </a:solidFill>
-            <a:prstDash val="solid"/>
-          </a:ln>
-        </p:spPr>
-      </p:sp>
-      <p:sp>
-        <p:nvSpPr>
-          <p:cNvPr id="16" name="Shape 13"/>
-          <p:cNvSpPr/>
-          <p:nvPr/>
-        </p:nvSpPr>
-        <p:spPr>
-          <a:xfrm>
-            <a:off x="7726680" y="0"/>
-            <a:ext cx="54864" cy="6858000"/>
-          </a:xfrm>
-          <a:prstGeom prst="rect">
-            <a:avLst/>
-          </a:prstGeom>
-          <a:solidFill>
-            <a:srgbClr val="0A8FA6"/>
-          </a:solidFill>
-          <a:ln w="12700">
-            <a:solidFill>
-              <a:srgbClr val="0A8FA6"/>
-            </a:solidFill>
-            <a:prstDash val="solid"/>
-          </a:ln>
-        </p:spPr>
-      </p:sp>
-      <p:sp>
-        <p:nvSpPr>
-          <p:cNvPr id="17" name="Text 14"/>
-          <p:cNvSpPr txBox="1"/>
-          <p:nvPr/>
-        </p:nvSpPr>
-        <p:spPr>
-          <a:xfrm>
-            <a:off x="8183880" y="548640"/>
-            <a:ext cx="3596335" cy="201168"/>
-          </a:xfrm>
-          <a:prstGeom prst="rect">
-            <a:avLst/>
-          </a:prstGeom>
-          <a:noFill/>
-          <a:ln/>
-        </p:spPr>
-        <p:txBody>
-          <a:bodyPr wrap="square" lIns="0" tIns="0" rIns="0" bIns="0" rtlCol="0" anchor="t"/>
-          <a:lstStyle/>
-          <a:p>
-            <a:pPr indent="0" marL="0">
-              <a:buNone/>
-            </a:pPr>
-            <a:r>
-              <a:rPr lang="en-US" sz="900" b="1" spc="150" kern="0" dirty="0">
-                <a:solidFill>
-                  <a:srgbClr val="7FD3E3"/>
-                </a:solidFill>
-                <a:latin typeface="Segoe UI" pitchFamily="34" charset="0"/>
-                <a:ea typeface="Segoe UI" pitchFamily="34" charset="-122"/>
-                <a:cs typeface="Segoe UI" pitchFamily="34" charset="-120"/>
-              </a:rPr>
-              <a:t>AT A GLANCE</a:t>
-            </a:r>
-            <a:endParaRPr lang="en-US" sz="900" dirty="0"/>
-          </a:p>
-        </p:txBody>
-      </p:sp>
-      <p:sp>
-        <p:nvSpPr>
-          <p:cNvPr id="18" name="Text 15"/>
-          <p:cNvSpPr txBox="1"/>
-          <p:nvPr/>
-        </p:nvSpPr>
-        <p:spPr>
-          <a:xfrm>
-            <a:off x="8183880" y="914400"/>
-            <a:ext cx="3596335" cy="566928"/>
-          </a:xfrm>
-          <a:prstGeom prst="rect">
-            <a:avLst/>
-          </a:prstGeom>
-          <a:noFill/>
-          <a:ln/>
-        </p:spPr>
-        <p:txBody>
-          <a:bodyPr wrap="square" lIns="0" tIns="0" rIns="0" bIns="0" rtlCol="0" anchor="t"/>
-          <a:lstStyle/>
-          <a:p>
-            <a:pPr indent="0" marL="0">
-              <a:buNone/>
-            </a:pPr>
-            <a:r>
-              <a:rPr lang="en-US" sz="3800" spc="-200" kern="0" dirty="0">
-                <a:solidFill>
-                  <a:srgbClr val="FFFFFF"/>
-                </a:solidFill>
-                <a:latin typeface="Segoe UI" pitchFamily="34" charset="0"/>
-                <a:ea typeface="Segoe UI" pitchFamily="34" charset="-122"/>
-                <a:cs typeface="Segoe UI" pitchFamily="34" charset="-120"/>
-              </a:rPr>
-              <a:t>+336%</a:t>
-            </a:r>
-            <a:endParaRPr lang="en-US" sz="3800" dirty="0"/>
-          </a:p>
-        </p:txBody>
-      </p:sp>
-      <p:sp>
-        <p:nvSpPr>
-          <p:cNvPr id="19" name="Text 16"/>
-          <p:cNvSpPr txBox="1"/>
-          <p:nvPr/>
-        </p:nvSpPr>
-        <p:spPr>
-          <a:xfrm>
-            <a:off x="8183880" y="1517904"/>
-            <a:ext cx="3596335" cy="457200"/>
-          </a:xfrm>
-          <a:prstGeom prst="rect">
-            <a:avLst/>
-          </a:prstGeom>
-          <a:noFill/>
-          <a:ln/>
-        </p:spPr>
-        <p:txBody>
-          <a:bodyPr wrap="square" lIns="0" tIns="0" rIns="0" bIns="0" rtlCol="0" anchor="t"/>
-          <a:lstStyle/>
-          <a:p>
-            <a:pPr indent="0" marL="0">
-              <a:lnSpc>
-                <a:spcPct val="120000"/>
-              </a:lnSpc>
-              <a:buNone/>
-            </a:pPr>
-            <a:r>
-              <a:rPr lang="en-US" sz="1050" dirty="0">
-                <a:solidFill>
-                  <a:srgbClr val="C5D6E8"/>
-                </a:solidFill>
-                <a:latin typeface="Segoe UI" pitchFamily="34" charset="0"/>
-                <a:ea typeface="Segoe UI" pitchFamily="34" charset="-122"/>
-                <a:cs typeface="Segoe UI" pitchFamily="34" charset="-120"/>
-              </a:rPr>
-              <a:t>Monthly TPL recoveries at Chicago-area partner hospitals, March – July 2026 ($33K → $144K)</a:t>
-            </a:r>
-            <a:endParaRPr lang="en-US" sz="1050" dirty="0"/>
-          </a:p>
-        </p:txBody>
-      </p:sp>
-      <p:sp>
-        <p:nvSpPr>
-          <p:cNvPr id="20" name="Shape 17"/>
-          <p:cNvSpPr/>
-          <p:nvPr/>
-        </p:nvSpPr>
-        <p:spPr>
-          <a:xfrm>
-            <a:off x="8183880" y="1993392"/>
-            <a:ext cx="3596335" cy="0"/>
-          </a:xfrm>
-          <a:prstGeom prst="line">
-            <a:avLst/>
-          </a:prstGeom>
-          <a:noFill/>
-          <a:ln w="9525">
-            <a:solidFill>
-              <a:srgbClr val="375F8F"/>
-            </a:solidFill>
-            <a:prstDash val="solid"/>
-          </a:ln>
-        </p:spPr>
-      </p:sp>
-      <p:sp>
-        <p:nvSpPr>
-          <p:cNvPr id="21" name="Text 18"/>
-          <p:cNvSpPr txBox="1"/>
-          <p:nvPr/>
-        </p:nvSpPr>
-        <p:spPr>
-          <a:xfrm>
-            <a:off x="8183880" y="2103120"/>
-            <a:ext cx="3596335" cy="566928"/>
-          </a:xfrm>
-          <a:prstGeom prst="rect">
-            <a:avLst/>
-          </a:prstGeom>
-          <a:noFill/>
-          <a:ln/>
-        </p:spPr>
-        <p:txBody>
-          <a:bodyPr wrap="square" lIns="0" tIns="0" rIns="0" bIns="0" rtlCol="0" anchor="t"/>
-          <a:lstStyle/>
-          <a:p>
-            <a:pPr indent="0" marL="0">
-              <a:buNone/>
-            </a:pPr>
-            <a:r>
-              <a:rPr lang="en-US" sz="3800" spc="-200" kern="0" dirty="0">
-                <a:solidFill>
-                  <a:srgbClr val="FFFFFF"/>
-                </a:solidFill>
-                <a:latin typeface="Segoe UI" pitchFamily="34" charset="0"/>
-                <a:ea typeface="Segoe UI" pitchFamily="34" charset="-122"/>
-                <a:cs typeface="Segoe UI" pitchFamily="34" charset="-120"/>
-              </a:rPr>
-              <a:t>90%+</a:t>
-            </a:r>
-            <a:endParaRPr lang="en-US" sz="3800" dirty="0"/>
-          </a:p>
-        </p:txBody>
-      </p:sp>
-      <p:sp>
-        <p:nvSpPr>
-          <p:cNvPr id="22" name="Text 19"/>
-          <p:cNvSpPr txBox="1"/>
-          <p:nvPr/>
-        </p:nvSpPr>
-        <p:spPr>
-          <a:xfrm>
-            <a:off x="8183880" y="2706624"/>
-            <a:ext cx="3596335" cy="457200"/>
-          </a:xfrm>
-          <a:prstGeom prst="rect">
-            <a:avLst/>
-          </a:prstGeom>
-          <a:noFill/>
-          <a:ln/>
-        </p:spPr>
-        <p:txBody>
-          <a:bodyPr wrap="square" lIns="0" tIns="0" rIns="0" bIns="0" rtlCol="0" anchor="t"/>
-          <a:lstStyle/>
-          <a:p>
-            <a:pPr indent="0" marL="0">
-              <a:lnSpc>
-                <a:spcPct val="120000"/>
-              </a:lnSpc>
-              <a:buNone/>
-            </a:pPr>
-            <a:r>
-              <a:rPr lang="en-US" sz="1050" dirty="0">
-                <a:solidFill>
-                  <a:srgbClr val="C5D6E8"/>
-                </a:solidFill>
-                <a:latin typeface="Segoe UI" pitchFamily="34" charset="0"/>
-                <a:ea typeface="Segoe UI" pitchFamily="34" charset="-122"/>
-                <a:cs typeface="Segoe UI" pitchFamily="34" charset="-120"/>
-              </a:rPr>
-              <a:t>Payer identification accuracy, up from under 30%</a:t>
-            </a:r>
-            <a:endParaRPr lang="en-US" sz="1050" dirty="0"/>
-          </a:p>
-        </p:txBody>
-      </p:sp>
-      <p:sp>
-        <p:nvSpPr>
-          <p:cNvPr id="23" name="Shape 20"/>
-          <p:cNvSpPr/>
-          <p:nvPr/>
-        </p:nvSpPr>
-        <p:spPr>
-          <a:xfrm>
-            <a:off x="8183880" y="3182112"/>
-            <a:ext cx="3596335" cy="0"/>
-          </a:xfrm>
-          <a:prstGeom prst="line">
-            <a:avLst/>
-          </a:prstGeom>
-          <a:noFill/>
-          <a:ln w="9525">
-            <a:solidFill>
-              <a:srgbClr val="375F8F"/>
-            </a:solidFill>
-            <a:prstDash val="solid"/>
-          </a:ln>
-        </p:spPr>
-      </p:sp>
-      <p:sp>
-        <p:nvSpPr>
-          <p:cNvPr id="24" name="Text 21"/>
-          <p:cNvSpPr txBox="1"/>
-          <p:nvPr/>
-        </p:nvSpPr>
-        <p:spPr>
-          <a:xfrm>
-            <a:off x="8183880" y="3291840"/>
-            <a:ext cx="3596335" cy="566928"/>
-          </a:xfrm>
-          <a:prstGeom prst="rect">
-            <a:avLst/>
-          </a:prstGeom>
-          <a:noFill/>
-          <a:ln/>
-        </p:spPr>
-        <p:txBody>
-          <a:bodyPr wrap="square" lIns="0" tIns="0" rIns="0" bIns="0" rtlCol="0" anchor="t"/>
-          <a:lstStyle/>
-          <a:p>
-            <a:pPr indent="0" marL="0">
-              <a:buNone/>
-            </a:pPr>
-            <a:r>
-              <a:rPr lang="en-US" sz="3800" spc="-200" kern="0" dirty="0">
-                <a:solidFill>
-                  <a:srgbClr val="FFFFFF"/>
-                </a:solidFill>
-                <a:latin typeface="Segoe UI" pitchFamily="34" charset="0"/>
-                <a:ea typeface="Segoe UI" pitchFamily="34" charset="-122"/>
-                <a:cs typeface="Segoe UI" pitchFamily="34" charset="-120"/>
-              </a:rPr>
-              <a:t>79%</a:t>
-            </a:r>
-            <a:endParaRPr lang="en-US" sz="3800" dirty="0"/>
-          </a:p>
-        </p:txBody>
-      </p:sp>
-      <p:sp>
-        <p:nvSpPr>
-          <p:cNvPr id="25" name="Text 22"/>
-          <p:cNvSpPr txBox="1"/>
-          <p:nvPr/>
-        </p:nvSpPr>
-        <p:spPr>
-          <a:xfrm>
-            <a:off x="8183880" y="3895344"/>
-            <a:ext cx="3596335" cy="457200"/>
-          </a:xfrm>
-          <a:prstGeom prst="rect">
-            <a:avLst/>
-          </a:prstGeom>
-          <a:noFill/>
-          <a:ln/>
-        </p:spPr>
-        <p:txBody>
-          <a:bodyPr wrap="square" lIns="0" tIns="0" rIns="0" bIns="0" rtlCol="0" anchor="t"/>
-          <a:lstStyle/>
-          <a:p>
-            <a:pPr indent="0" marL="0">
-              <a:lnSpc>
-                <a:spcPct val="120000"/>
-              </a:lnSpc>
-              <a:buNone/>
-            </a:pPr>
-            <a:r>
-              <a:rPr lang="en-US" sz="1050" dirty="0">
-                <a:solidFill>
-                  <a:srgbClr val="C5D6E8"/>
-                </a:solidFill>
-                <a:latin typeface="Segoe UI" pitchFamily="34" charset="0"/>
-                <a:ea typeface="Segoe UI" pitchFamily="34" charset="-122"/>
-                <a:cs typeface="Segoe UI" pitchFamily="34" charset="-120"/>
-              </a:rPr>
-              <a:t>Of screened July encounters verified (141 of 178)</a:t>
-            </a:r>
-            <a:endParaRPr lang="en-US" sz="1050" dirty="0"/>
-          </a:p>
-        </p:txBody>
-      </p:sp>
-      <p:sp>
-        <p:nvSpPr>
-          <p:cNvPr id="26" name="Shape 23"/>
+        </p:txBody>
+      </p:sp>
+      <p:sp>
+        <p:nvSpPr>
+          <p:cNvPr id="19" name="Shape 17"/>
           <p:cNvSpPr/>
           <p:nvPr/>
         </p:nvSpPr>
@@ -3258,7 +2970,7 @@
       </p:sp>
       <p:sp>
         <p:nvSpPr>
-          <p:cNvPr id="27" name="Text 24"/>
+          <p:cNvPr id="20" name="Text 18"/>
           <p:cNvSpPr txBox="1"/>
           <p:nvPr/>
         </p:nvSpPr>
@@ -3297,7 +3009,7 @@
       </p:sp>
       <p:sp>
         <p:nvSpPr>
-          <p:cNvPr id="28" name="Text 25"/>
+          <p:cNvPr id="21" name="Text 19"/>
           <p:cNvSpPr txBox="1"/>
           <p:nvPr/>
         </p:nvSpPr>
@@ -3336,7 +3048,7 @@
       </p:sp>
       <p:sp>
         <p:nvSpPr>
-          <p:cNvPr id="29" name="Text 26"/>
+          <p:cNvPr id="22" name="Text 20"/>
           <p:cNvSpPr txBox="1"/>
           <p:nvPr/>
         </p:nvSpPr>

</xml_diff>

<commit_message>
PPTX closing slide: small logo tile in the bottom-left corner
Matches the HTML: a 58 px-equivalent white rounded tile at the left margin,
directly above the footer line, with "Thank you" bottom-right aligned to it.

Co-Authored-By: Claude Fable 5.1 <noreply@anthropic.com>
</commit_message>
<xml_diff>
--- a/LaborForce_CookCountyHealth.pptx
+++ b/LaborForce_CookCountyHealth.pptx
@@ -287,7 +287,7 @@
           <c:smooth val="0"/>
           <c:extLst>
             <c:ext xmlns:c16="http://schemas.microsoft.com/office/drawing/2014/chart" uri="{C3380CC4-5D6E-409C-BE32-E72D297353CC}">
-              <c16:uniqueId val="{00000000-D605-469F-ACB8-8A13E82ECF5F}"/>
+              <c16:uniqueId val="{00000000-B892-469A-9AB3-8CE08ED4EC0F}"/>
             </c:ext>
           </c:extLst>
         </c:ser>
@@ -478,7 +478,7 @@
     </p:spTree>
     <p:extLst>
       <p:ext uri="{BB962C8B-B14F-4D97-AF65-F5344CB8AC3E}">
-        <p14:creationId xmlns:p14="http://schemas.microsoft.com/office/powerpoint/2010/main" val="3272148917"/>
+        <p14:creationId xmlns:p14="http://schemas.microsoft.com/office/powerpoint/2010/main" val="1142065826"/>
       </p:ext>
     </p:extLst>
   </p:cSld>
@@ -3549,12 +3549,12 @@
         </p:nvSpPr>
         <p:spPr>
           <a:xfrm>
-            <a:off x="548640" y="4892040"/>
-            <a:ext cx="2011680" cy="1234440"/>
+            <a:off x="548640" y="5779008"/>
+            <a:ext cx="777240" cy="493776"/>
           </a:xfrm>
           <a:prstGeom prst="roundRect">
             <a:avLst>
-              <a:gd name="adj" fmla="val 3704"/>
+              <a:gd name="adj" fmla="val 7407"/>
             </a:avLst>
           </a:prstGeom>
           <a:solidFill>
@@ -3584,8 +3584,8 @@
         </p:blipFill>
         <p:spPr>
           <a:xfrm>
-            <a:off x="822960" y="5029200"/>
-            <a:ext cx="1463040" cy="962863"/>
+            <a:off x="666383" y="5847588"/>
+            <a:ext cx="541755" cy="356616"/>
           </a:xfrm>
           <a:prstGeom prst="rect">
             <a:avLst/>
@@ -3600,8 +3600,8 @@
         </p:nvSpPr>
         <p:spPr>
           <a:xfrm>
-            <a:off x="7619695" y="5303520"/>
-            <a:ext cx="4023360" cy="274320"/>
+            <a:off x="7619695" y="5733288"/>
+            <a:ext cx="4023360" cy="256032"/>
           </a:xfrm>
           <a:prstGeom prst="rect">
             <a:avLst/>
@@ -3639,8 +3639,8 @@
         </p:nvSpPr>
         <p:spPr>
           <a:xfrm>
-            <a:off x="7619695" y="5605272"/>
-            <a:ext cx="4023360" cy="457200"/>
+            <a:off x="7619695" y="6007608"/>
+            <a:ext cx="4023360" cy="274320"/>
           </a:xfrm>
           <a:prstGeom prst="rect">
             <a:avLst/>
@@ -3653,9 +3653,6 @@
           <a:lstStyle/>
           <a:p>
             <a:pPr marL="0" indent="0" algn="r">
-              <a:lnSpc>
-                <a:spcPct val="125000"/>
-              </a:lnSpc>
               <a:buNone/>
             </a:pPr>
             <a:r>

</xml_diff>

<commit_message>
PPTX slide 3: restore the "Whether ..." wording and original intro line
Matches the HTML on main (52cf644): intro ends "capture or resolve:" and the
six question cards use the earlier "Whether ..." phrasing.

Co-Authored-By: Claude Fable 5.1 <noreply@anthropic.com>
</commit_message>
<xml_diff>
--- a/LaborForce_CookCountyHealth.pptx
+++ b/LaborForce_CookCountyHealth.pptx
@@ -287,7 +287,7 @@
           <c:smooth val="0"/>
           <c:extLst>
             <c:ext xmlns:c16="http://schemas.microsoft.com/office/drawing/2014/chart" uri="{C3380CC4-5D6E-409C-BE32-E72D297353CC}">
-              <c16:uniqueId val="{00000000-B892-469A-9AB3-8CE08ED4EC0F}"/>
+              <c16:uniqueId val="{00000000-0EA7-4AA0-96A2-8760E52A399A}"/>
             </c:ext>
           </c:extLst>
         </c:ser>
@@ -478,7 +478,7 @@
     </p:spTree>
     <p:extLst>
       <p:ext uri="{BB962C8B-B14F-4D97-AF65-F5344CB8AC3E}">
-        <p14:creationId xmlns:p14="http://schemas.microsoft.com/office/powerpoint/2010/main" val="1142065826"/>
+        <p14:creationId xmlns:p14="http://schemas.microsoft.com/office/powerpoint/2010/main" val="1314938084"/>
       </p:ext>
     </p:extLst>
   </p:cSld>
@@ -5165,7 +5165,7 @@
                 <a:ea typeface="Segoe UI" pitchFamily="34" charset="-122"/>
                 <a:cs typeface="Segoe UI" pitchFamily="34" charset="-120"/>
               </a:rPr>
-              <a:t>Patients often arrive after workplace incidents, motor vehicle accidents, or injuries involving another liable party. Registration and billing workflows may not consistently answer:</a:t>
+              <a:t>Patients often arrive after workplace incidents, motor vehicle accidents, or injuries involving another liable party. Registration and billing workflows may not consistently capture or resolve:</a:t>
             </a:r>
             <a:endParaRPr lang="en-US" sz="1200" dirty="0"/>
           </a:p>
@@ -5298,7 +5298,7 @@
                 <a:ea typeface="Segoe UI" pitchFamily="34" charset="-122"/>
                 <a:cs typeface="Segoe UI" pitchFamily="34" charset="-120"/>
               </a:rPr>
-              <a:t>Was the injury work-related?</a:t>
+              <a:t>Whether the injury occurred while the patient was working</a:t>
             </a:r>
             <a:endParaRPr lang="en-US" sz="1250" dirty="0"/>
           </a:p>
@@ -5431,7 +5431,7 @@
                 <a:ea typeface="Segoe UI" pitchFamily="34" charset="-122"/>
                 <a:cs typeface="Segoe UI" pitchFamily="34" charset="-120"/>
               </a:rPr>
-              <a:t>Is a motor vehicle or other third party responsible?</a:t>
+              <a:t>Whether a motor vehicle or other third party may be responsible</a:t>
             </a:r>
             <a:endParaRPr lang="en-US" sz="1250" dirty="0"/>
           </a:p>
@@ -5564,7 +5564,7 @@
                 <a:ea typeface="Segoe UI" pitchFamily="34" charset="-122"/>
                 <a:cs typeface="Segoe UI" pitchFamily="34" charset="-120"/>
               </a:rPr>
-              <a:t>Should another insurer or payer be investigated?</a:t>
+              <a:t>Whether another insurer or payer should be investigated</a:t>
             </a:r>
             <a:endParaRPr lang="en-US" sz="1250" dirty="0"/>
           </a:p>
@@ -5697,7 +5697,7 @@
                 <a:ea typeface="Segoe UI" pitchFamily="34" charset="-122"/>
                 <a:cs typeface="Segoe UI" pitchFamily="34" charset="-120"/>
               </a:rPr>
-              <a:t>Does the hospital have the right claim, attorney, and payer information?</a:t>
+              <a:t>Whether the hospital has the right claim, attorney, or payer information</a:t>
             </a:r>
             <a:endParaRPr lang="en-US" sz="1250" dirty="0"/>
           </a:p>
@@ -5830,7 +5830,7 @@
                 <a:ea typeface="Segoe UI" pitchFamily="34" charset="-122"/>
                 <a:cs typeface="Segoe UI" pitchFamily="34" charset="-120"/>
               </a:rPr>
-              <a:t>Is a hospital lien available, documented, and followed up?</a:t>
+              <a:t>Whether a hospital lien is available, documented, and followed up</a:t>
             </a:r>
             <a:endParaRPr lang="en-US" sz="1250" dirty="0"/>
           </a:p>
@@ -5963,7 +5963,7 @@
                 <a:ea typeface="Segoe UI" pitchFamily="34" charset="-122"/>
                 <a:cs typeface="Segoe UI" pitchFamily="34" charset="-120"/>
               </a:rPr>
-              <a:t>Are unresolved cases investigated after discharge?</a:t>
+              <a:t>Whether unresolved cases need investigation after discharge</a:t>
             </a:r>
             <a:endParaRPr lang="en-US" sz="1250" dirty="0"/>
           </a:p>

</xml_diff>

<commit_message>
PPTX cover: remove the At a glance panel; photo fills the right side
One-column cover to match the web deck (ca21850): tagline, title, subtitle and
hospital partner logos on the left; the faded hospital photo now spans 62% x 84%
of the slide, anchored bottom-right. Footer unchanged.

Co-Authored-By: Claude Fable 5.1 <noreply@anthropic.com>
</commit_message>
<xml_diff>
--- a/LaborForce_CookCountyHealth.pptx
+++ b/LaborForce_CookCountyHealth.pptx
@@ -285,7 +285,7 @@
           <c:smooth val="0"/>
           <c:extLst>
             <c:ext xmlns:c16="http://schemas.microsoft.com/office/drawing/2014/chart" uri="{C3380CC4-5D6E-409C-BE32-E72D297353CC}">
-              <c16:uniqueId val="{00000000-5F47-4F74-9131-5AB155F9E9A8}"/>
+              <c16:uniqueId val="{00000000-55A6-46D3-A391-B7E3119AEF41}"/>
             </c:ext>
           </c:extLst>
         </c:ser>
@@ -476,7 +476,7 @@
     </p:spTree>
     <p:extLst>
       <p:ext uri="{BB962C8B-B14F-4D97-AF65-F5344CB8AC3E}">
-        <p14:creationId xmlns:p14="http://schemas.microsoft.com/office/powerpoint/2010/main" val="4134428290"/>
+        <p14:creationId xmlns:p14="http://schemas.microsoft.com/office/powerpoint/2010/main" val="3096133236"/>
       </p:ext>
     </p:extLst>
   </p:cSld>
@@ -622,7 +622,7 @@
           <a:p>
             <a:r>
               <a:rPr lang="en-US" dirty="0"/>
-              <a:t>Cover. Program results are program-reported figures from Chicago-area partner hospitals, March–July 2026; not independently attributed.</a:t>
+              <a:t>Cover: one column, hospital photo on the right. The right-hand stats panel was removed on 2026-10-26 to match the web deck.</a:t>
             </a:r>
           </a:p>
         </p:txBody>
@@ -1924,8 +1924,8 @@
         </p:blipFill>
         <p:spPr>
           <a:xfrm>
-            <a:off x="2468880" y="1783080"/>
-            <a:ext cx="5257800" cy="5074920"/>
+            <a:off x="4629607" y="1097280"/>
+            <a:ext cx="7562088" cy="5760720"/>
           </a:xfrm>
           <a:prstGeom prst="rect">
             <a:avLst/>
@@ -2289,528 +2289,6 @@
               <a:t>01 / 08</a:t>
             </a:r>
             <a:endParaRPr lang="en-US" sz="800" dirty="0"/>
-          </a:p>
-        </p:txBody>
-      </p:sp>
-      <p:sp>
-        <p:nvSpPr>
-          <p:cNvPr id="13" name="Shape 8"/>
-          <p:cNvSpPr/>
-          <p:nvPr/>
-        </p:nvSpPr>
-        <p:spPr>
-          <a:xfrm>
-            <a:off x="7726680" y="0"/>
-            <a:ext cx="4465015" cy="6858000"/>
-          </a:xfrm>
-          <a:prstGeom prst="rect">
-            <a:avLst/>
-          </a:prstGeom>
-          <a:solidFill>
-            <a:srgbClr val="0C3C75"/>
-          </a:solidFill>
-          <a:ln w="12700">
-            <a:solidFill>
-              <a:srgbClr val="0C3C75"/>
-            </a:solidFill>
-            <a:prstDash val="solid"/>
-          </a:ln>
-        </p:spPr>
-      </p:sp>
-      <p:sp>
-        <p:nvSpPr>
-          <p:cNvPr id="14" name="Shape 9"/>
-          <p:cNvSpPr/>
-          <p:nvPr/>
-        </p:nvSpPr>
-        <p:spPr>
-          <a:xfrm>
-            <a:off x="7726680" y="0"/>
-            <a:ext cx="54864" cy="6858000"/>
-          </a:xfrm>
-          <a:prstGeom prst="rect">
-            <a:avLst/>
-          </a:prstGeom>
-          <a:solidFill>
-            <a:srgbClr val="0A8FA6"/>
-          </a:solidFill>
-          <a:ln w="12700">
-            <a:solidFill>
-              <a:srgbClr val="0A8FA6"/>
-            </a:solidFill>
-            <a:prstDash val="solid"/>
-          </a:ln>
-        </p:spPr>
-      </p:sp>
-      <p:sp>
-        <p:nvSpPr>
-          <p:cNvPr id="15" name="Text 10"/>
-          <p:cNvSpPr txBox="1"/>
-          <p:nvPr/>
-        </p:nvSpPr>
-        <p:spPr>
-          <a:xfrm>
-            <a:off x="8183880" y="548640"/>
-            <a:ext cx="3596335" cy="201168"/>
-          </a:xfrm>
-          <a:prstGeom prst="rect">
-            <a:avLst/>
-          </a:prstGeom>
-          <a:noFill/>
-          <a:ln/>
-        </p:spPr>
-        <p:txBody>
-          <a:bodyPr wrap="square" lIns="0" tIns="0" rIns="0" bIns="0" rtlCol="0" anchor="t"/>
-          <a:lstStyle/>
-          <a:p>
-            <a:pPr marL="0" indent="0">
-              <a:buNone/>
-            </a:pPr>
-            <a:r>
-              <a:rPr lang="en-US" sz="900" b="1" kern="0" spc="150" dirty="0">
-                <a:solidFill>
-                  <a:srgbClr val="7FD3E3"/>
-                </a:solidFill>
-                <a:latin typeface="Segoe UI" pitchFamily="34" charset="0"/>
-                <a:ea typeface="Segoe UI" pitchFamily="34" charset="-122"/>
-                <a:cs typeface="Segoe UI" pitchFamily="34" charset="-120"/>
-              </a:rPr>
-              <a:t>AT A GLANCE</a:t>
-            </a:r>
-            <a:endParaRPr lang="en-US" sz="900" dirty="0"/>
-          </a:p>
-        </p:txBody>
-      </p:sp>
-      <p:sp>
-        <p:nvSpPr>
-          <p:cNvPr id="16" name="Text 11"/>
-          <p:cNvSpPr txBox="1"/>
-          <p:nvPr/>
-        </p:nvSpPr>
-        <p:spPr>
-          <a:xfrm>
-            <a:off x="8183880" y="914400"/>
-            <a:ext cx="3596335" cy="566928"/>
-          </a:xfrm>
-          <a:prstGeom prst="rect">
-            <a:avLst/>
-          </a:prstGeom>
-          <a:noFill/>
-          <a:ln/>
-        </p:spPr>
-        <p:txBody>
-          <a:bodyPr wrap="square" lIns="0" tIns="0" rIns="0" bIns="0" rtlCol="0" anchor="t"/>
-          <a:lstStyle/>
-          <a:p>
-            <a:pPr marL="0" indent="0">
-              <a:buNone/>
-            </a:pPr>
-            <a:r>
-              <a:rPr lang="en-US" sz="3800" kern="0" spc="-200" dirty="0">
-                <a:solidFill>
-                  <a:srgbClr val="FFFFFF"/>
-                </a:solidFill>
-                <a:latin typeface="Segoe UI" pitchFamily="34" charset="0"/>
-                <a:ea typeface="Segoe UI" pitchFamily="34" charset="-122"/>
-                <a:cs typeface="Segoe UI" pitchFamily="34" charset="-120"/>
-              </a:rPr>
-              <a:t>+336%</a:t>
-            </a:r>
-            <a:endParaRPr lang="en-US" sz="3800" dirty="0"/>
-          </a:p>
-        </p:txBody>
-      </p:sp>
-      <p:sp>
-        <p:nvSpPr>
-          <p:cNvPr id="17" name="Text 12"/>
-          <p:cNvSpPr txBox="1"/>
-          <p:nvPr/>
-        </p:nvSpPr>
-        <p:spPr>
-          <a:xfrm>
-            <a:off x="8183880" y="1517904"/>
-            <a:ext cx="3596335" cy="457200"/>
-          </a:xfrm>
-          <a:prstGeom prst="rect">
-            <a:avLst/>
-          </a:prstGeom>
-          <a:noFill/>
-          <a:ln/>
-        </p:spPr>
-        <p:txBody>
-          <a:bodyPr wrap="square" lIns="0" tIns="0" rIns="0" bIns="0" rtlCol="0" anchor="t"/>
-          <a:lstStyle/>
-          <a:p>
-            <a:pPr marL="0" indent="0">
-              <a:lnSpc>
-                <a:spcPct val="120000"/>
-              </a:lnSpc>
-              <a:buNone/>
-            </a:pPr>
-            <a:r>
-              <a:rPr lang="en-US" sz="1050" dirty="0">
-                <a:solidFill>
-                  <a:srgbClr val="C5D6E8"/>
-                </a:solidFill>
-                <a:latin typeface="Segoe UI" pitchFamily="34" charset="0"/>
-                <a:ea typeface="Segoe UI" pitchFamily="34" charset="-122"/>
-                <a:cs typeface="Segoe UI" pitchFamily="34" charset="-120"/>
-              </a:rPr>
-              <a:t>Monthly TPL recoveries at Chicago-area partner hospitals, March – July 2026 ($33K → $144K)</a:t>
-            </a:r>
-            <a:endParaRPr lang="en-US" sz="1050" dirty="0"/>
-          </a:p>
-        </p:txBody>
-      </p:sp>
-      <p:sp>
-        <p:nvSpPr>
-          <p:cNvPr id="18" name="Shape 13"/>
-          <p:cNvSpPr/>
-          <p:nvPr/>
-        </p:nvSpPr>
-        <p:spPr>
-          <a:xfrm>
-            <a:off x="8183880" y="1993392"/>
-            <a:ext cx="3596335" cy="0"/>
-          </a:xfrm>
-          <a:prstGeom prst="line">
-            <a:avLst/>
-          </a:prstGeom>
-          <a:noFill/>
-          <a:ln w="9525">
-            <a:solidFill>
-              <a:srgbClr val="375F8F"/>
-            </a:solidFill>
-            <a:prstDash val="solid"/>
-          </a:ln>
-        </p:spPr>
-      </p:sp>
-      <p:sp>
-        <p:nvSpPr>
-          <p:cNvPr id="19" name="Text 14"/>
-          <p:cNvSpPr txBox="1"/>
-          <p:nvPr/>
-        </p:nvSpPr>
-        <p:spPr>
-          <a:xfrm>
-            <a:off x="8183880" y="2103120"/>
-            <a:ext cx="3596335" cy="566928"/>
-          </a:xfrm>
-          <a:prstGeom prst="rect">
-            <a:avLst/>
-          </a:prstGeom>
-          <a:noFill/>
-          <a:ln/>
-        </p:spPr>
-        <p:txBody>
-          <a:bodyPr wrap="square" lIns="0" tIns="0" rIns="0" bIns="0" rtlCol="0" anchor="t"/>
-          <a:lstStyle/>
-          <a:p>
-            <a:pPr marL="0" indent="0">
-              <a:buNone/>
-            </a:pPr>
-            <a:r>
-              <a:rPr lang="en-US" sz="3800" kern="0" spc="-200" dirty="0">
-                <a:solidFill>
-                  <a:srgbClr val="FFFFFF"/>
-                </a:solidFill>
-                <a:latin typeface="Segoe UI" pitchFamily="34" charset="0"/>
-                <a:ea typeface="Segoe UI" pitchFamily="34" charset="-122"/>
-                <a:cs typeface="Segoe UI" pitchFamily="34" charset="-120"/>
-              </a:rPr>
-              <a:t>90%+</a:t>
-            </a:r>
-            <a:endParaRPr lang="en-US" sz="3800" dirty="0"/>
-          </a:p>
-        </p:txBody>
-      </p:sp>
-      <p:sp>
-        <p:nvSpPr>
-          <p:cNvPr id="20" name="Text 15"/>
-          <p:cNvSpPr txBox="1"/>
-          <p:nvPr/>
-        </p:nvSpPr>
-        <p:spPr>
-          <a:xfrm>
-            <a:off x="8183880" y="2706624"/>
-            <a:ext cx="3596335" cy="457200"/>
-          </a:xfrm>
-          <a:prstGeom prst="rect">
-            <a:avLst/>
-          </a:prstGeom>
-          <a:noFill/>
-          <a:ln/>
-        </p:spPr>
-        <p:txBody>
-          <a:bodyPr wrap="square" lIns="0" tIns="0" rIns="0" bIns="0" rtlCol="0" anchor="t"/>
-          <a:lstStyle/>
-          <a:p>
-            <a:pPr marL="0" indent="0">
-              <a:lnSpc>
-                <a:spcPct val="120000"/>
-              </a:lnSpc>
-              <a:buNone/>
-            </a:pPr>
-            <a:r>
-              <a:rPr lang="en-US" sz="1050" dirty="0">
-                <a:solidFill>
-                  <a:srgbClr val="C5D6E8"/>
-                </a:solidFill>
-                <a:latin typeface="Segoe UI" pitchFamily="34" charset="0"/>
-                <a:ea typeface="Segoe UI" pitchFamily="34" charset="-122"/>
-                <a:cs typeface="Segoe UI" pitchFamily="34" charset="-120"/>
-              </a:rPr>
-              <a:t>Payer identification accuracy, up from under 30%</a:t>
-            </a:r>
-            <a:endParaRPr lang="en-US" sz="1050" dirty="0"/>
-          </a:p>
-        </p:txBody>
-      </p:sp>
-      <p:sp>
-        <p:nvSpPr>
-          <p:cNvPr id="21" name="Shape 16"/>
-          <p:cNvSpPr/>
-          <p:nvPr/>
-        </p:nvSpPr>
-        <p:spPr>
-          <a:xfrm>
-            <a:off x="8183880" y="3182112"/>
-            <a:ext cx="3596335" cy="0"/>
-          </a:xfrm>
-          <a:prstGeom prst="line">
-            <a:avLst/>
-          </a:prstGeom>
-          <a:noFill/>
-          <a:ln w="9525">
-            <a:solidFill>
-              <a:srgbClr val="375F8F"/>
-            </a:solidFill>
-            <a:prstDash val="solid"/>
-          </a:ln>
-        </p:spPr>
-      </p:sp>
-      <p:sp>
-        <p:nvSpPr>
-          <p:cNvPr id="22" name="Text 17"/>
-          <p:cNvSpPr txBox="1"/>
-          <p:nvPr/>
-        </p:nvSpPr>
-        <p:spPr>
-          <a:xfrm>
-            <a:off x="8183880" y="3291840"/>
-            <a:ext cx="3596335" cy="566928"/>
-          </a:xfrm>
-          <a:prstGeom prst="rect">
-            <a:avLst/>
-          </a:prstGeom>
-          <a:noFill/>
-          <a:ln/>
-        </p:spPr>
-        <p:txBody>
-          <a:bodyPr wrap="square" lIns="0" tIns="0" rIns="0" bIns="0" rtlCol="0" anchor="t"/>
-          <a:lstStyle/>
-          <a:p>
-            <a:pPr marL="0" indent="0">
-              <a:buNone/>
-            </a:pPr>
-            <a:r>
-              <a:rPr lang="en-US" sz="3800" kern="0" spc="-200" dirty="0">
-                <a:solidFill>
-                  <a:srgbClr val="FFFFFF"/>
-                </a:solidFill>
-                <a:latin typeface="Segoe UI" pitchFamily="34" charset="0"/>
-                <a:ea typeface="Segoe UI" pitchFamily="34" charset="-122"/>
-                <a:cs typeface="Segoe UI" pitchFamily="34" charset="-120"/>
-              </a:rPr>
-              <a:t>79%</a:t>
-            </a:r>
-            <a:endParaRPr lang="en-US" sz="3800" dirty="0"/>
-          </a:p>
-        </p:txBody>
-      </p:sp>
-      <p:sp>
-        <p:nvSpPr>
-          <p:cNvPr id="23" name="Text 18"/>
-          <p:cNvSpPr txBox="1"/>
-          <p:nvPr/>
-        </p:nvSpPr>
-        <p:spPr>
-          <a:xfrm>
-            <a:off x="8183880" y="3895344"/>
-            <a:ext cx="3596335" cy="457200"/>
-          </a:xfrm>
-          <a:prstGeom prst="rect">
-            <a:avLst/>
-          </a:prstGeom>
-          <a:noFill/>
-          <a:ln/>
-        </p:spPr>
-        <p:txBody>
-          <a:bodyPr wrap="square" lIns="0" tIns="0" rIns="0" bIns="0" rtlCol="0" anchor="t"/>
-          <a:lstStyle/>
-          <a:p>
-            <a:pPr marL="0" indent="0">
-              <a:lnSpc>
-                <a:spcPct val="120000"/>
-              </a:lnSpc>
-              <a:buNone/>
-            </a:pPr>
-            <a:r>
-              <a:rPr lang="en-US" sz="1050" dirty="0">
-                <a:solidFill>
-                  <a:srgbClr val="C5D6E8"/>
-                </a:solidFill>
-                <a:latin typeface="Segoe UI" pitchFamily="34" charset="0"/>
-                <a:ea typeface="Segoe UI" pitchFamily="34" charset="-122"/>
-                <a:cs typeface="Segoe UI" pitchFamily="34" charset="-120"/>
-              </a:rPr>
-              <a:t>Of screened July encounters verified (141 of 178)</a:t>
-            </a:r>
-            <a:endParaRPr lang="en-US" sz="1050" dirty="0"/>
-          </a:p>
-        </p:txBody>
-      </p:sp>
-      <p:sp>
-        <p:nvSpPr>
-          <p:cNvPr id="24" name="Shape 19"/>
-          <p:cNvSpPr/>
-          <p:nvPr/>
-        </p:nvSpPr>
-        <p:spPr>
-          <a:xfrm>
-            <a:off x="8092440" y="4754880"/>
-            <a:ext cx="3779215" cy="914400"/>
-          </a:xfrm>
-          <a:prstGeom prst="roundRect">
-            <a:avLst>
-              <a:gd name="adj" fmla="val 4000"/>
-            </a:avLst>
-          </a:prstGeom>
-          <a:solidFill>
-            <a:srgbClr val="1D4A7F"/>
-          </a:solidFill>
-          <a:ln w="12700">
-            <a:solidFill>
-              <a:srgbClr val="1D4A7F"/>
-            </a:solidFill>
-            <a:prstDash val="solid"/>
-          </a:ln>
-        </p:spPr>
-      </p:sp>
-      <p:sp>
-        <p:nvSpPr>
-          <p:cNvPr id="25" name="Text 20"/>
-          <p:cNvSpPr txBox="1"/>
-          <p:nvPr/>
-        </p:nvSpPr>
-        <p:spPr>
-          <a:xfrm>
-            <a:off x="8275320" y="4937760"/>
-            <a:ext cx="3596335" cy="201168"/>
-          </a:xfrm>
-          <a:prstGeom prst="rect">
-            <a:avLst/>
-          </a:prstGeom>
-          <a:noFill/>
-          <a:ln/>
-        </p:spPr>
-        <p:txBody>
-          <a:bodyPr wrap="square" lIns="0" tIns="0" rIns="0" bIns="0" rtlCol="0" anchor="t"/>
-          <a:lstStyle/>
-          <a:p>
-            <a:pPr marL="0" indent="0">
-              <a:buNone/>
-            </a:pPr>
-            <a:r>
-              <a:rPr lang="en-US" sz="800" b="1" kern="0" spc="150" dirty="0">
-                <a:solidFill>
-                  <a:srgbClr val="7FD3E3"/>
-                </a:solidFill>
-                <a:latin typeface="Segoe UI" pitchFamily="34" charset="0"/>
-                <a:ea typeface="Segoe UI" pitchFamily="34" charset="-122"/>
-                <a:cs typeface="Segoe UI" pitchFamily="34" charset="-120"/>
-              </a:rPr>
-              <a:t>THE ASK</a:t>
-            </a:r>
-            <a:endParaRPr lang="en-US" sz="800" dirty="0"/>
-          </a:p>
-        </p:txBody>
-      </p:sp>
-      <p:sp>
-        <p:nvSpPr>
-          <p:cNvPr id="26" name="Text 21"/>
-          <p:cNvSpPr txBox="1"/>
-          <p:nvPr/>
-        </p:nvSpPr>
-        <p:spPr>
-          <a:xfrm>
-            <a:off x="8275320" y="5175504"/>
-            <a:ext cx="3413455" cy="365760"/>
-          </a:xfrm>
-          <a:prstGeom prst="rect">
-            <a:avLst/>
-          </a:prstGeom>
-          <a:noFill/>
-          <a:ln/>
-        </p:spPr>
-        <p:txBody>
-          <a:bodyPr wrap="square" lIns="0" tIns="0" rIns="0" bIns="0" rtlCol="0" anchor="t"/>
-          <a:lstStyle/>
-          <a:p>
-            <a:pPr marL="0" indent="0">
-              <a:buNone/>
-            </a:pPr>
-            <a:r>
-              <a:rPr lang="en-US" sz="1250" b="1" dirty="0">
-                <a:solidFill>
-                  <a:srgbClr val="FFFFFF"/>
-                </a:solidFill>
-                <a:latin typeface="Segoe UI" pitchFamily="34" charset="0"/>
-                <a:ea typeface="Segoe UI" pitchFamily="34" charset="-122"/>
-                <a:cs typeface="Segoe UI" pitchFamily="34" charset="-120"/>
-              </a:rPr>
-              <a:t>A 90-day pilot at John H. Stroger, Jr. Hospital</a:t>
-            </a:r>
-            <a:endParaRPr lang="en-US" sz="1250" dirty="0"/>
-          </a:p>
-        </p:txBody>
-      </p:sp>
-      <p:sp>
-        <p:nvSpPr>
-          <p:cNvPr id="27" name="Text 22"/>
-          <p:cNvSpPr txBox="1"/>
-          <p:nvPr/>
-        </p:nvSpPr>
-        <p:spPr>
-          <a:xfrm>
-            <a:off x="8183880" y="6080760"/>
-            <a:ext cx="3596335" cy="228600"/>
-          </a:xfrm>
-          <a:prstGeom prst="rect">
-            <a:avLst/>
-          </a:prstGeom>
-          <a:noFill/>
-          <a:ln/>
-        </p:spPr>
-        <p:txBody>
-          <a:bodyPr wrap="square" lIns="0" tIns="0" rIns="0" bIns="0" rtlCol="0" anchor="t"/>
-          <a:lstStyle/>
-          <a:p>
-            <a:pPr marL="0" indent="0">
-              <a:buNone/>
-            </a:pPr>
-            <a:r>
-              <a:rPr lang="en-US" sz="900" dirty="0">
-                <a:solidFill>
-                  <a:srgbClr val="8EA4BB"/>
-                </a:solidFill>
-                <a:latin typeface="Segoe UI" pitchFamily="34" charset="0"/>
-                <a:ea typeface="Segoe UI" pitchFamily="34" charset="-122"/>
-                <a:cs typeface="Segoe UI" pitchFamily="34" charset="-120"/>
-              </a:rPr>
-              <a:t>Program-reported figures; not independently attributed.</a:t>
-            </a:r>
-            <a:endParaRPr lang="en-US" sz="900" dirty="0"/>
           </a:p>
         </p:txBody>
       </p:sp>

</xml_diff>

<commit_message>
PPTX/PDF slide 3: kicker "03 | Where revenue slips"
Co-Authored-By: Claude Fable 5.1 <noreply@anthropic.com>
</commit_message>
<xml_diff>
--- a/LaborForce_CookCountyHealth.pptx
+++ b/LaborForce_CookCountyHealth.pptx
@@ -285,7 +285,7 @@
           <c:smooth val="0"/>
           <c:extLst>
             <c:ext xmlns:c16="http://schemas.microsoft.com/office/drawing/2014/chart" uri="{C3380CC4-5D6E-409C-BE32-E72D297353CC}">
-              <c16:uniqueId val="{00000000-55A6-46D3-A391-B7E3119AEF41}"/>
+              <c16:uniqueId val="{00000000-AAD3-49B1-BEE3-D2118833B345}"/>
             </c:ext>
           </c:extLst>
         </c:ser>
@@ -476,7 +476,7 @@
     </p:spTree>
     <p:extLst>
       <p:ext uri="{BB962C8B-B14F-4D97-AF65-F5344CB8AC3E}">
-        <p14:creationId xmlns:p14="http://schemas.microsoft.com/office/powerpoint/2010/main" val="3096133236"/>
+        <p14:creationId xmlns:p14="http://schemas.microsoft.com/office/powerpoint/2010/main" val="2246086052"/>
       </p:ext>
     </p:extLst>
   </p:cSld>
@@ -3664,7 +3664,7 @@
                 <a:ea typeface="Segoe UI" pitchFamily="34" charset="-122"/>
                 <a:cs typeface="Segoe UI" pitchFamily="34" charset="-120"/>
               </a:rPr>
-              <a:t>THE CHALLENGE</a:t>
+              <a:t>WHERE REVENUE SLIPS</a:t>
             </a:r>
             <a:endParaRPr lang="en-US" sz="900" dirty="0"/>
           </a:p>

</xml_diff>

<commit_message>
PPTX/PDF: document title is exactly "LaborForce Medical Management"
Metadata only; no slide content changed.

Co-Authored-By: Claude Fable 5.1 <noreply@anthropic.com>
</commit_message>
<xml_diff>
--- a/LaborForce_CookCountyHealth.pptx
+++ b/LaborForce_CookCountyHealth.pptx
@@ -281,7 +281,7 @@
           <c:smooth val="0"/>
           <c:extLst>
             <c:ext xmlns:c16="http://schemas.microsoft.com/office/drawing/2014/chart" uri="{C3380CC4-5D6E-409C-BE32-E72D297353CC}">
-              <c16:uniqueId val="{00000000-234D-4DC3-A4CF-C38A51468B18}"/>
+              <c16:uniqueId val="{00000000-1DA7-452F-9D22-A773B8445B50}"/>
             </c:ext>
           </c:extLst>
         </c:ser>
@@ -472,7 +472,7 @@
     </p:spTree>
     <p:extLst>
       <p:ext uri="{BB962C8B-B14F-4D97-AF65-F5344CB8AC3E}">
-        <p14:creationId xmlns:p14="http://schemas.microsoft.com/office/powerpoint/2010/main" val="3161609155"/>
+        <p14:creationId xmlns:p14="http://schemas.microsoft.com/office/powerpoint/2010/main" val="432250452"/>
       </p:ext>
     </p:extLst>
   </p:cSld>

</xml_diff>